<commit_message>
Add target customers (ICP) and go-to-market to the pitch: slide 7 route and new appendix A2
Five target customers and the route (associations and KOLs co-develop, ISO 13485 QMS, CE marking class IIa), as decided by the team; README updated.

Co-Authored-By: Claude Opus 5.5 <noreply@anthropic.com>
</commit_message>
<xml_diff>
--- a/pitch/ADHD_Check_Pitch.pptx
+++ b/pitch/ADHD_Check_Pitch.pptx
@@ -18,6 +18,7 @@
     <p:sldId id="263" r:id="rId12"/>
     <p:sldId id="271" r:id="rId13"/>
     <p:sldId id="264" r:id="rId14"/>
+    <p:sldId id="265" r:id="rId15"/>
     <p:sldId id="267" r:id="rId17"/>
     <p:sldId id="270" r:id="rId20"/>
   </p:sldIdLst>
@@ -818,6 +819,92 @@
 </p:notes>
 </file>
 
+<file path=ppt/notesSlides/notesSlide11.xml><?xml version="1.0" encoding="utf-8"?>
+<p:notes xmlns:a="http://schemas.openxmlformats.org/drawingml/2006/main" xmlns:r="http://schemas.openxmlformats.org/officeDocument/2006/relationships" xmlns:p="http://schemas.openxmlformats.org/presentationml/2006/main">
+  <p:cSld>
+    <p:spTree>
+      <p:nvGrpSpPr>
+        <p:cNvPr id="1" name=""/>
+        <p:cNvGrpSpPr/>
+        <p:nvPr/>
+      </p:nvGrpSpPr>
+      <p:grpSpPr>
+        <a:xfrm>
+          <a:off x="0" y="0"/>
+          <a:ext cx="0" cy="0"/>
+          <a:chOff x="0" y="0"/>
+          <a:chExt cx="0" cy="0"/>
+        </a:xfrm>
+      </p:grpSpPr>
+      <p:sp>
+        <p:nvSpPr>
+          <p:cNvPr id="2" name="Slide Image Placeholder 1"/>
+          <p:cNvSpPr>
+            <a:spLocks noGrp="1" noRot="1" noChangeAspect="1"/>
+          </p:cNvSpPr>
+          <p:nvPr>
+            <p:ph type="sldImg"/>
+          </p:nvPr>
+        </p:nvSpPr>
+        <p:spPr/>
+      </p:sp>
+      <p:sp>
+        <p:nvSpPr>
+          <p:cNvPr id="3" name="Notes Placeholder 2"/>
+          <p:cNvSpPr>
+            <a:spLocks noGrp="1"/>
+          </p:cNvSpPr>
+          <p:nvPr>
+            <p:ph type="body" idx="1"/>
+          </p:nvPr>
+        </p:nvSpPr>
+        <p:spPr/>
+        <p:txBody>
+          <a:bodyPr/>
+          <a:lstStyle/>
+          <a:p>
+            <a:r>
+              <a:t>For questions on who buys and how we reach the market. Five target customers: parents, ADHD associations, teachers, nurses (children play in the waiting room before the visit) and GPs. Go-to-market: co-develop with the associations and leading doctors in Romania, their validation drives adoption, then ISO 13485 and CE marking class IIa.</a:t>
+            </a:r>
+          </a:p>
+        </p:txBody>
+      </p:sp>
+      <p:sp>
+        <p:nvSpPr>
+          <p:cNvPr id="4" name="Slide Number Placeholder 3"/>
+          <p:cNvSpPr>
+            <a:spLocks noGrp="1"/>
+          </p:cNvSpPr>
+          <p:nvPr>
+            <p:ph type="sldNum" sz="quarter" idx="10"/>
+          </p:nvPr>
+        </p:nvSpPr>
+        <p:spPr/>
+        <p:txBody>
+          <a:bodyPr/>
+          <a:lstStyle/>
+          <a:p>
+            <a:fld id="{F7021451-1387-4CA6-816F-3879F97B5CBC}" type="slidenum">
+              <a:rPr lang="en-US"/>
+              <a:t>11</a:t>
+            </a:fld>
+            <a:endParaRPr lang="en-US"/>
+          </a:p>
+        </p:txBody>
+      </p:sp>
+    </p:spTree>
+    <p:extLst>
+      <p:ext uri="{BB962C8B-B14F-4D97-AF65-F5344CB8AC3E}">
+        <p14:creationId xmlns:p14="http://schemas.microsoft.com/office/powerpoint/2010/main" val="1024086991"/>
+      </p:ext>
+    </p:extLst>
+  </p:cSld>
+  <p:clrMapOvr>
+    <a:masterClrMapping/>
+  </p:clrMapOvr>
+</p:notes>
+</file>
+
 <file path=ppt/notesSlides/notesSlide13.xml><?xml version="1.0" encoding="utf-8"?>
 <p:notes xmlns:a="http://schemas.openxmlformats.org/drawingml/2006/main" xmlns:r="http://schemas.openxmlformats.org/officeDocument/2006/relationships" xmlns:p="http://schemas.openxmlformats.org/presentationml/2006/main">
   <p:cSld>
@@ -1465,7 +1552,7 @@
           <a:lstStyle/>
           <a:p>
             <a:r>
-              <a:t>About 20 seconds. Safe by design: the child profile is a nickname and birth year; camera and microphone are designed to stay off by default and be processed on the device, not built yet. No ADHD probability and no severity. Expected EU MDR class IIa under Rule 11, to confirm. Next: a pilot with a child psychiatry partner.</a:t>
+              <a:t>About 20 seconds. Safe by design: the child profile is a nickname and birth year; camera and microphone are designed to stay off by default and be processed on the device, not built yet. No ADHD probability and no severity. Our route: we co-develop with the Romanian ADHD associations and the leading doctors; their validation drives adoption. Then a quality management system per ISO 13485 and CE marking under EU MDR, expected class IIa.</a:t>
             </a:r>
           </a:p>
         </p:txBody>
@@ -1551,7 +1638,7 @@
           <a:lstStyle/>
           <a:p>
             <a:r>
-              <a:t>About 15 seconds. This is our team [names and roles]. Our ask: a clinical partner, to run a validation pilot in Romania. Thank you. If asked a question: excellent question, I have a slide for that (appendix A1 stakeholders, A2 costs, A3 sources).</a:t>
+              <a:t>About 15 seconds. This is our team [names and roles]. Our ask: a clinical partner, to run a validation pilot in Romania. Thank you. If asked a question: excellent question, I have a slide for that (appendix A1 stakeholders, A2 customers and go-to-market, A3 costs, A4 sources).</a:t>
             </a:r>
           </a:p>
         </p:txBody>
@@ -3596,6 +3683,989 @@
 </p:sld>
 </file>
 
+<file path=ppt/slides/slide11.xml><?xml version="1.0" encoding="utf-8"?>
+<p:sld xmlns:a="http://schemas.openxmlformats.org/drawingml/2006/main" xmlns:r="http://schemas.openxmlformats.org/officeDocument/2006/relationships" xmlns:p="http://schemas.openxmlformats.org/presentationml/2006/main">
+  <p:cSld name="Slide 10">
+    <p:bg>
+      <p:bgPr>
+        <a:solidFill>
+          <a:srgbClr val="FFFFFF"/>
+        </a:solidFill>
+        <a:effectLst/>
+      </p:bgPr>
+    </p:bg>
+    <p:spTree>
+      <p:nvGrpSpPr>
+        <p:cNvPr id="1" name=""/>
+        <p:cNvGrpSpPr/>
+        <p:nvPr/>
+      </p:nvGrpSpPr>
+      <p:grpSpPr>
+        <a:xfrm>
+          <a:off x="0" y="0"/>
+          <a:ext cx="1" cy="1"/>
+          <a:chOff x="0" y="0"/>
+          <a:chExt cx="1" cy="1"/>
+        </a:xfrm>
+      </p:grpSpPr>
+      <p:sp>
+        <p:nvSpPr>
+          <p:cNvPr id="2" name="Shape 0"/>
+          <p:cNvSpPr/>
+          <p:nvPr/>
+        </p:nvSpPr>
+        <p:spPr>
+          <a:xfrm>
+            <a:off x="0" y="0"/>
+            <a:ext cx="128016" cy="6858000"/>
+          </a:xfrm>
+          <a:prstGeom prst="rect">
+            <a:avLst/>
+          </a:prstGeom>
+          <a:gradFill rotWithShape="1">
+            <a:gsLst>
+              <a:gs pos="0">
+                <a:srgbClr val="FF5757"/>
+              </a:gs>
+              <a:gs pos="100000">
+                <a:srgbClr val="8C52FF"/>
+              </a:gs>
+            </a:gsLst>
+            <a:lin ang="5400000" scaled="1"/>
+          </a:gradFill>
+          <a:ln w="12700">
+            <a:solidFill>
+              <a:srgbClr val="8C52FF"/>
+            </a:solidFill>
+            <a:prstDash val="solid"/>
+          </a:ln>
+        </p:spPr>
+        <p:txBody>
+          <a:bodyPr/>
+          <a:lstStyle/>
+          <a:p>
+            <a:endParaRPr lang="en-US"/>
+          </a:p>
+        </p:txBody>
+      </p:sp>
+      <p:sp>
+        <p:nvSpPr>
+          <p:cNvPr id="3" name="Text 1"/>
+          <p:cNvSpPr/>
+          <p:nvPr/>
+        </p:nvSpPr>
+        <p:spPr>
+          <a:xfrm>
+            <a:off x="502920" y="274320"/>
+            <a:ext cx="10972800" cy="228600"/>
+          </a:xfrm>
+          <a:prstGeom prst="rect">
+            <a:avLst/>
+          </a:prstGeom>
+          <a:noFill/>
+          <a:ln/>
+        </p:spPr>
+        <p:txBody>
+          <a:bodyPr wrap="square" lIns="0" tIns="0" rIns="0" bIns="0" rtlCol="0" anchor="ctr"/>
+          <a:lstStyle/>
+          <a:p>
+            <a:pPr marL="0" indent="0">
+              <a:buNone/>
+            </a:pPr>
+            <a:r>
+              <a:rPr lang="en-US" sz="1000" b="1">
+                <a:solidFill>
+                  <a:srgbClr val="2B5FAD"/>
+                </a:solidFill>
+                <a:latin typeface="Aptos" pitchFamily="34" charset="0"/>
+                <a:ea typeface="Aptos" pitchFamily="34" charset="-122"/>
+                <a:cs typeface="Aptos" pitchFamily="34" charset="-120"/>
+              </a:rPr>
+              <a:t>OPTIONAL APPENDIX / USE ONLY IF NEEDED</a:t>
+            </a:r>
+            <a:endParaRPr lang="en-US" sz="1000"/>
+          </a:p>
+        </p:txBody>
+      </p:sp>
+      <p:sp>
+        <p:nvSpPr>
+          <p:cNvPr id="4" name="Text 2"/>
+          <p:cNvSpPr/>
+          <p:nvPr/>
+        </p:nvSpPr>
+        <p:spPr>
+          <a:xfrm>
+            <a:off x="502920" y="822960"/>
+            <a:ext cx="11155680" cy="594360"/>
+          </a:xfrm>
+          <a:prstGeom prst="rect">
+            <a:avLst/>
+          </a:prstGeom>
+          <a:noFill/>
+          <a:ln/>
+        </p:spPr>
+        <p:txBody>
+          <a:bodyPr wrap="square" lIns="0" tIns="0" rIns="0" bIns="0" rtlCol="0" anchor="ctr"/>
+          <a:lstStyle/>
+          <a:p>
+            <a:pPr marL="0" indent="0">
+              <a:buNone/>
+            </a:pPr>
+            <a:r>
+              <a:rPr lang="en-US" sz="3100" b="1">
+                <a:solidFill>
+                  <a:srgbClr val="263E73"/>
+                </a:solidFill>
+                <a:latin typeface="Aptos" pitchFamily="34" charset="0"/>
+                <a:ea typeface="Aptos" pitchFamily="34" charset="-122"/>
+                <a:cs typeface="Aptos" pitchFamily="34" charset="-120"/>
+              </a:rPr>
+              <a:t>Target customers and go-to-market</a:t>
+            </a:r>
+            <a:endParaRPr lang="en-US" sz="3100"/>
+          </a:p>
+        </p:txBody>
+      </p:sp>
+      <p:sp>
+        <p:nvSpPr>
+          <p:cNvPr id="5" name="Text 3"/>
+          <p:cNvSpPr/>
+          <p:nvPr/>
+        </p:nvSpPr>
+        <p:spPr>
+          <a:xfrm>
+            <a:off x="502920" y="1508760"/>
+            <a:ext cx="11064240" cy="457200"/>
+          </a:xfrm>
+          <a:prstGeom prst="rect">
+            <a:avLst/>
+          </a:prstGeom>
+          <a:noFill/>
+          <a:ln/>
+        </p:spPr>
+        <p:txBody>
+          <a:bodyPr wrap="square" lIns="0" tIns="0" rIns="0" bIns="0" rtlCol="0" anchor="ctr"/>
+          <a:lstStyle/>
+          <a:p>
+            <a:pPr marL="0" indent="0">
+              <a:buNone/>
+            </a:pPr>
+            <a:r>
+              <a:rPr lang="en-US" sz="1600">
+                <a:solidFill>
+                  <a:srgbClr val="59657B"/>
+                </a:solidFill>
+                <a:latin typeface="Aptos" pitchFamily="34" charset="0"/>
+                <a:ea typeface="Aptos" pitchFamily="34" charset="-122"/>
+                <a:cs typeface="Aptos" pitchFamily="34" charset="-120"/>
+              </a:rPr>
+              <a:t>Optional A2: who we sell to and how we reach the market.</a:t>
+            </a:r>
+            <a:endParaRPr lang="en-US" sz="1600"/>
+          </a:p>
+        </p:txBody>
+      </p:sp>
+      <p:sp>
+        <p:nvSpPr>
+          <p:cNvPr id="6" name="Text 4"/>
+          <p:cNvSpPr/>
+          <p:nvPr/>
+        </p:nvSpPr>
+        <p:spPr>
+          <a:xfrm>
+            <a:off x="502920" y="6428232"/>
+            <a:ext cx="8229600" cy="210312"/>
+          </a:xfrm>
+          <a:prstGeom prst="rect">
+            <a:avLst/>
+          </a:prstGeom>
+          <a:noFill/>
+          <a:ln/>
+        </p:spPr>
+        <p:txBody>
+          <a:bodyPr wrap="square" lIns="0" tIns="0" rIns="0" bIns="0" rtlCol="0" anchor="ctr"/>
+          <a:lstStyle/>
+          <a:p>
+            <a:pPr marL="0" indent="0">
+              <a:buNone/>
+            </a:pPr>
+            <a:r>
+              <a:rPr lang="en-US" sz="1000">
+                <a:solidFill>
+                  <a:srgbClr val="59657B"/>
+                </a:solidFill>
+                <a:latin typeface="Aptos" pitchFamily="34" charset="0"/>
+                <a:ea typeface="Aptos" pitchFamily="34" charset="-122"/>
+                <a:cs typeface="Aptos" pitchFamily="34" charset="-120"/>
+              </a:rPr>
+              <a:t>Team name TODO | ADHD Check</a:t>
+            </a:r>
+            <a:endParaRPr lang="en-US" sz="1000"/>
+          </a:p>
+        </p:txBody>
+      </p:sp>
+      <p:sp>
+        <p:nvSpPr>
+          <p:cNvPr id="7" name="Text 5"/>
+          <p:cNvSpPr/>
+          <p:nvPr/>
+        </p:nvSpPr>
+        <p:spPr>
+          <a:xfrm>
+            <a:off x="9875520" y="6419088"/>
+            <a:ext cx="1783080" cy="228600"/>
+          </a:xfrm>
+          <a:prstGeom prst="rect">
+            <a:avLst/>
+          </a:prstGeom>
+          <a:noFill/>
+          <a:ln/>
+        </p:spPr>
+        <p:txBody>
+          <a:bodyPr wrap="square" lIns="0" tIns="0" rIns="0" bIns="0" rtlCol="0" anchor="ctr"/>
+          <a:lstStyle/>
+          <a:p>
+            <a:pPr marL="0" indent="0">
+              <a:buNone/>
+            </a:pPr>
+            <a:r>
+              <a:rPr lang="en-US" sz="1000" b="1">
+                <a:solidFill>
+                  <a:srgbClr val="2B5FAD"/>
+                </a:solidFill>
+                <a:latin typeface="Aptos" pitchFamily="34" charset="0"/>
+                <a:ea typeface="Aptos" pitchFamily="34" charset="-122"/>
+                <a:cs typeface="Aptos" pitchFamily="34" charset="-120"/>
+              </a:rPr>
+              <a:t>A2 / OPTIONAL</a:t>
+            </a:r>
+            <a:endParaRPr lang="en-US" sz="1000"/>
+          </a:p>
+        </p:txBody>
+      </p:sp>
+      <p:sp>
+        <p:nvSpPr>
+          <p:cNvPr id="8" name="Shape 6"/>
+          <p:cNvSpPr/>
+          <p:nvPr/>
+        </p:nvSpPr>
+        <p:spPr>
+          <a:xfrm>
+            <a:off x="502920" y="2286000"/>
+            <a:ext cx="3520440" cy="3017520"/>
+          </a:xfrm>
+          <a:prstGeom prst="roundRect">
+            <a:avLst>
+              <a:gd name="adj" fmla="val 3030"/>
+            </a:avLst>
+          </a:prstGeom>
+          <a:solidFill>
+            <a:srgbClr val="F0F1FA"/>
+          </a:solidFill>
+          <a:ln w="12700">
+            <a:solidFill>
+              <a:srgbClr val="F0F1FA"/>
+            </a:solidFill>
+            <a:prstDash val="solid"/>
+          </a:ln>
+        </p:spPr>
+        <p:txBody>
+          <a:bodyPr/>
+          <a:lstStyle/>
+          <a:p>
+            <a:endParaRPr lang="en-US"/>
+          </a:p>
+        </p:txBody>
+      </p:sp>
+      <p:sp>
+        <p:nvSpPr>
+          <p:cNvPr id="9" name="Text 7"/>
+          <p:cNvSpPr/>
+          <p:nvPr/>
+        </p:nvSpPr>
+        <p:spPr>
+          <a:xfrm>
+            <a:off x="704088" y="2450592"/>
+            <a:ext cx="3118104" cy="274320"/>
+          </a:xfrm>
+          <a:prstGeom prst="rect">
+            <a:avLst/>
+          </a:prstGeom>
+          <a:noFill/>
+          <a:ln/>
+        </p:spPr>
+        <p:txBody>
+          <a:bodyPr wrap="square" lIns="0" tIns="0" rIns="0" bIns="0" rtlCol="0" anchor="ctr"/>
+          <a:lstStyle/>
+          <a:p>
+            <a:pPr marL="0" indent="0">
+              <a:buNone/>
+            </a:pPr>
+            <a:r>
+              <a:rPr lang="en-US" sz="1100" b="1">
+                <a:solidFill>
+                  <a:srgbClr val="2B5FAD"/>
+                </a:solidFill>
+                <a:latin typeface="Aptos" pitchFamily="34" charset="0"/>
+                <a:ea typeface="Aptos" pitchFamily="34" charset="-122"/>
+                <a:cs typeface="Aptos" pitchFamily="34" charset="-120"/>
+              </a:rPr>
+              <a:t>TARGET CUSTOMERS (ICP)</a:t>
+            </a:r>
+            <a:endParaRPr lang="en-US" sz="1100"/>
+          </a:p>
+        </p:txBody>
+      </p:sp>
+      <p:sp>
+        <p:nvSpPr>
+          <p:cNvPr id="10" name="Text 8"/>
+          <p:cNvSpPr/>
+          <p:nvPr/>
+        </p:nvSpPr>
+        <p:spPr>
+          <a:xfrm>
+            <a:off x="704088" y="2944368"/>
+            <a:ext cx="3118104" cy="2148840"/>
+          </a:xfrm>
+          <a:prstGeom prst="rect">
+            <a:avLst/>
+          </a:prstGeom>
+          <a:noFill/>
+          <a:ln/>
+        </p:spPr>
+        <p:txBody>
+          <a:bodyPr wrap="square" lIns="0" tIns="0" rIns="0" bIns="0" rtlCol="0" anchor="ctr"/>
+          <a:lstStyle/>
+          <a:p>
+            <a:pPr marL="0" indent="0">
+              <a:buNone/>
+            </a:pPr>
+            <a:r>
+              <a:rPr lang="en-US" sz="1200" b="1">
+                <a:solidFill>
+                  <a:srgbClr val="263E73"/>
+                </a:solidFill>
+                <a:latin typeface="Aptos" pitchFamily="34" charset="0"/>
+                <a:ea typeface="Aptos" pitchFamily="34" charset="-122"/>
+                <a:cs typeface="Aptos" pitchFamily="34" charset="-120"/>
+              </a:rPr>
+              <a:t>Parents: </a:t>
+            </a:r>
+            <a:r>
+              <a:rPr lang="en-US" sz="1200">
+                <a:solidFill>
+                  <a:srgbClr val="263E73"/>
+                </a:solidFill>
+                <a:latin typeface="Aptos" pitchFamily="34" charset="0"/>
+                <a:ea typeface="Aptos" pitchFamily="34" charset="-122"/>
+                <a:cs typeface="Aptos" pitchFamily="34" charset="-120"/>
+              </a:rPr>
+              <a:t>of children aged 6 to 12</a:t>
+            </a:r>
+            <a:endParaRPr lang="en-US" sz="1200"/>
+          </a:p>
+          <a:p>
+            <a:pPr marL="0" indent="0">
+              <a:buNone/>
+            </a:pPr>
+            <a:endParaRPr lang="en-US" sz="500"/>
+          </a:p>
+          <a:p>
+            <a:pPr marL="0" indent="0">
+              <a:buNone/>
+            </a:pPr>
+            <a:r>
+              <a:rPr lang="en-US" sz="1200" b="1">
+                <a:solidFill>
+                  <a:srgbClr val="263E73"/>
+                </a:solidFill>
+                <a:latin typeface="Aptos" pitchFamily="34" charset="0"/>
+                <a:ea typeface="Aptos" pitchFamily="34" charset="-122"/>
+                <a:cs typeface="Aptos" pitchFamily="34" charset="-120"/>
+              </a:rPr>
+              <a:t>ADHD associations: </a:t>
+            </a:r>
+            <a:r>
+              <a:rPr lang="en-US" sz="1200">
+                <a:solidFill>
+                  <a:srgbClr val="263E73"/>
+                </a:solidFill>
+                <a:latin typeface="Aptos" pitchFamily="34" charset="0"/>
+                <a:ea typeface="Aptos" pitchFamily="34" charset="-122"/>
+                <a:cs typeface="Aptos" pitchFamily="34" charset="-120"/>
+              </a:rPr>
+              <a:t>in each country we advertise in</a:t>
+            </a:r>
+            <a:endParaRPr lang="en-US" sz="1200"/>
+          </a:p>
+          <a:p>
+            <a:pPr marL="0" indent="0">
+              <a:buNone/>
+            </a:pPr>
+            <a:endParaRPr lang="en-US" sz="500"/>
+          </a:p>
+          <a:p>
+            <a:pPr marL="0" indent="0">
+              <a:buNone/>
+            </a:pPr>
+            <a:r>
+              <a:rPr lang="en-US" sz="1200" b="1">
+                <a:solidFill>
+                  <a:srgbClr val="263E73"/>
+                </a:solidFill>
+                <a:latin typeface="Aptos" pitchFamily="34" charset="0"/>
+                <a:ea typeface="Aptos" pitchFamily="34" charset="-122"/>
+                <a:cs typeface="Aptos" pitchFamily="34" charset="-120"/>
+              </a:rPr>
+              <a:t>Teachers: </a:t>
+            </a:r>
+            <a:r>
+              <a:rPr lang="en-US" sz="1200">
+                <a:solidFill>
+                  <a:srgbClr val="263E73"/>
+                </a:solidFill>
+                <a:latin typeface="Aptos" pitchFamily="34" charset="0"/>
+                <a:ea typeface="Aptos" pitchFamily="34" charset="-122"/>
+                <a:cs typeface="Aptos" pitchFamily="34" charset="-120"/>
+              </a:rPr>
+              <a:t>who notice attention problems in class</a:t>
+            </a:r>
+            <a:endParaRPr lang="en-US" sz="1200"/>
+          </a:p>
+          <a:p>
+            <a:pPr marL="0" indent="0">
+              <a:buNone/>
+            </a:pPr>
+            <a:endParaRPr lang="en-US" sz="500"/>
+          </a:p>
+          <a:p>
+            <a:pPr marL="0" indent="0">
+              <a:buNone/>
+            </a:pPr>
+            <a:r>
+              <a:rPr lang="en-US" sz="1200" b="1">
+                <a:solidFill>
+                  <a:srgbClr val="263E73"/>
+                </a:solidFill>
+                <a:latin typeface="Aptos" pitchFamily="34" charset="0"/>
+                <a:ea typeface="Aptos" pitchFamily="34" charset="-122"/>
+                <a:cs typeface="Aptos" pitchFamily="34" charset="-120"/>
+              </a:rPr>
+              <a:t>Nurses: </a:t>
+            </a:r>
+            <a:r>
+              <a:rPr lang="en-US" sz="1200">
+                <a:solidFill>
+                  <a:srgbClr val="263E73"/>
+                </a:solidFill>
+                <a:latin typeface="Aptos" pitchFamily="34" charset="0"/>
+                <a:ea typeface="Aptos" pitchFamily="34" charset="-122"/>
+                <a:cs typeface="Aptos" pitchFamily="34" charset="-120"/>
+              </a:rPr>
+              <a:t>children play in the waiting room before the visit</a:t>
+            </a:r>
+            <a:endParaRPr lang="en-US" sz="1200"/>
+          </a:p>
+          <a:p>
+            <a:pPr marL="0" indent="0">
+              <a:buNone/>
+            </a:pPr>
+            <a:endParaRPr lang="en-US" sz="500"/>
+          </a:p>
+          <a:p>
+            <a:pPr marL="0" indent="0">
+              <a:buNone/>
+            </a:pPr>
+            <a:r>
+              <a:rPr lang="en-US" sz="1200" b="1">
+                <a:solidFill>
+                  <a:srgbClr val="263E73"/>
+                </a:solidFill>
+                <a:latin typeface="Aptos" pitchFamily="34" charset="0"/>
+                <a:ea typeface="Aptos" pitchFamily="34" charset="-122"/>
+                <a:cs typeface="Aptos" pitchFamily="34" charset="-120"/>
+              </a:rPr>
+              <a:t>GPs: </a:t>
+            </a:r>
+            <a:r>
+              <a:rPr lang="en-US" sz="1200">
+                <a:solidFill>
+                  <a:srgbClr val="263E73"/>
+                </a:solidFill>
+                <a:latin typeface="Aptos" pitchFamily="34" charset="0"/>
+                <a:ea typeface="Aptos" pitchFamily="34" charset="-122"/>
+                <a:cs typeface="Aptos" pitchFamily="34" charset="-120"/>
+              </a:rPr>
+              <a:t>a first orientation before referral</a:t>
+            </a:r>
+            <a:endParaRPr lang="en-US" sz="1200"/>
+          </a:p>
+        </p:txBody>
+      </p:sp>
+      <p:sp>
+        <p:nvSpPr>
+          <p:cNvPr id="11" name="Shape 9"/>
+          <p:cNvSpPr/>
+          <p:nvPr/>
+        </p:nvSpPr>
+        <p:spPr>
+          <a:xfrm>
+            <a:off x="4320540" y="2286000"/>
+            <a:ext cx="3520440" cy="3017520"/>
+          </a:xfrm>
+          <a:prstGeom prst="roundRect">
+            <a:avLst>
+              <a:gd name="adj" fmla="val 3030"/>
+            </a:avLst>
+          </a:prstGeom>
+          <a:solidFill>
+            <a:srgbClr val="F0F1FA"/>
+          </a:solidFill>
+          <a:ln w="12700">
+            <a:solidFill>
+              <a:srgbClr val="F0F1FA"/>
+            </a:solidFill>
+            <a:prstDash val="solid"/>
+          </a:ln>
+        </p:spPr>
+        <p:txBody>
+          <a:bodyPr/>
+          <a:lstStyle/>
+          <a:p>
+            <a:endParaRPr lang="en-US"/>
+          </a:p>
+        </p:txBody>
+      </p:sp>
+      <p:sp>
+        <p:nvSpPr>
+          <p:cNvPr id="12" name="Text 10"/>
+          <p:cNvSpPr/>
+          <p:nvPr/>
+        </p:nvSpPr>
+        <p:spPr>
+          <a:xfrm>
+            <a:off x="4521708" y="2450592"/>
+            <a:ext cx="3118104" cy="274320"/>
+          </a:xfrm>
+          <a:prstGeom prst="rect">
+            <a:avLst/>
+          </a:prstGeom>
+          <a:noFill/>
+          <a:ln/>
+        </p:spPr>
+        <p:txBody>
+          <a:bodyPr wrap="square" lIns="0" tIns="0" rIns="0" bIns="0" rtlCol="0" anchor="ctr"/>
+          <a:lstStyle/>
+          <a:p>
+            <a:pPr marL="0" indent="0">
+              <a:buNone/>
+            </a:pPr>
+            <a:r>
+              <a:rPr lang="en-US" sz="1100" b="1">
+                <a:solidFill>
+                  <a:srgbClr val="8C52FF"/>
+                </a:solidFill>
+                <a:latin typeface="Aptos" pitchFamily="34" charset="0"/>
+                <a:ea typeface="Aptos" pitchFamily="34" charset="-122"/>
+                <a:cs typeface="Aptos" pitchFamily="34" charset="-120"/>
+              </a:rPr>
+              <a:t>GO-TO-MARKET</a:t>
+            </a:r>
+            <a:endParaRPr lang="en-US" sz="1100"/>
+          </a:p>
+        </p:txBody>
+      </p:sp>
+      <p:sp>
+        <p:nvSpPr>
+          <p:cNvPr id="13" name="Text 11"/>
+          <p:cNvSpPr/>
+          <p:nvPr/>
+        </p:nvSpPr>
+        <p:spPr>
+          <a:xfrm>
+            <a:off x="4521708" y="2944368"/>
+            <a:ext cx="3118104" cy="2148840"/>
+          </a:xfrm>
+          <a:prstGeom prst="rect">
+            <a:avLst/>
+          </a:prstGeom>
+          <a:noFill/>
+          <a:ln/>
+        </p:spPr>
+        <p:txBody>
+          <a:bodyPr wrap="square" lIns="0" tIns="0" rIns="0" bIns="0" rtlCol="0" anchor="ctr"/>
+          <a:lstStyle/>
+          <a:p>
+            <a:pPr marL="0" indent="0">
+              <a:buNone/>
+            </a:pPr>
+            <a:r>
+              <a:rPr lang="en-US" sz="1300">
+                <a:solidFill>
+                  <a:srgbClr val="263E73"/>
+                </a:solidFill>
+                <a:latin typeface="Aptos" pitchFamily="34" charset="0"/>
+                <a:ea typeface="Aptos" pitchFamily="34" charset="-122"/>
+                <a:cs typeface="Aptos" pitchFamily="34" charset="-120"/>
+              </a:rPr>
+              <a:t>1. Contact the Romanian ADHD associations and the leading doctors (KOLs)</a:t>
+            </a:r>
+            <a:endParaRPr lang="en-US" sz="1300"/>
+          </a:p>
+          <a:p>
+            <a:pPr marL="0" indent="0">
+              <a:buNone/>
+            </a:pPr>
+            <a:endParaRPr lang="en-US" sz="500"/>
+          </a:p>
+          <a:p>
+            <a:pPr marL="0" indent="0">
+              <a:buNone/>
+            </a:pPr>
+            <a:r>
+              <a:rPr lang="en-US" sz="1300">
+                <a:solidFill>
+                  <a:srgbClr val="263E73"/>
+                </a:solidFill>
+                <a:latin typeface="Aptos" pitchFamily="34" charset="0"/>
+                <a:ea typeface="Aptos" pitchFamily="34" charset="-122"/>
+                <a:cs typeface="Aptos" pitchFamily="34" charset="-120"/>
+              </a:rPr>
+              <a:t>2. Co-develop and improve the app with them</a:t>
+            </a:r>
+            <a:endParaRPr lang="en-US" sz="1300"/>
+          </a:p>
+          <a:p>
+            <a:pPr marL="0" indent="0">
+              <a:buNone/>
+            </a:pPr>
+            <a:endParaRPr lang="en-US" sz="500"/>
+          </a:p>
+          <a:p>
+            <a:pPr marL="0" indent="0">
+              <a:buNone/>
+            </a:pPr>
+            <a:r>
+              <a:rPr lang="en-US" sz="1300">
+                <a:solidFill>
+                  <a:srgbClr val="263E73"/>
+                </a:solidFill>
+                <a:latin typeface="Aptos" pitchFamily="34" charset="0"/>
+                <a:ea typeface="Aptos" pitchFamily="34" charset="-122"/>
+                <a:cs typeface="Aptos" pitchFamily="34" charset="-120"/>
+              </a:rPr>
+              <a:t>3. Their validation drives adoption</a:t>
+            </a:r>
+            <a:endParaRPr lang="en-US" sz="1300"/>
+          </a:p>
+        </p:txBody>
+      </p:sp>
+      <p:sp>
+        <p:nvSpPr>
+          <p:cNvPr id="14" name="Shape 12"/>
+          <p:cNvSpPr/>
+          <p:nvPr/>
+        </p:nvSpPr>
+        <p:spPr>
+          <a:xfrm>
+            <a:off x="8138160" y="2286000"/>
+            <a:ext cx="3520440" cy="3017520"/>
+          </a:xfrm>
+          <a:prstGeom prst="roundRect">
+            <a:avLst>
+              <a:gd name="adj" fmla="val 3030"/>
+            </a:avLst>
+          </a:prstGeom>
+          <a:solidFill>
+            <a:srgbClr val="F0F1FA"/>
+          </a:solidFill>
+          <a:ln w="12700">
+            <a:solidFill>
+              <a:srgbClr val="F0F1FA"/>
+            </a:solidFill>
+            <a:prstDash val="solid"/>
+          </a:ln>
+        </p:spPr>
+        <p:txBody>
+          <a:bodyPr/>
+          <a:lstStyle/>
+          <a:p>
+            <a:endParaRPr lang="en-US"/>
+          </a:p>
+        </p:txBody>
+      </p:sp>
+      <p:sp>
+        <p:nvSpPr>
+          <p:cNvPr id="15" name="Text 13"/>
+          <p:cNvSpPr/>
+          <p:nvPr/>
+        </p:nvSpPr>
+        <p:spPr>
+          <a:xfrm>
+            <a:off x="8339328" y="2450592"/>
+            <a:ext cx="3118104" cy="274320"/>
+          </a:xfrm>
+          <a:prstGeom prst="rect">
+            <a:avLst/>
+          </a:prstGeom>
+          <a:noFill/>
+          <a:ln/>
+        </p:spPr>
+        <p:txBody>
+          <a:bodyPr wrap="square" lIns="0" tIns="0" rIns="0" bIns="0" rtlCol="0" anchor="ctr"/>
+          <a:lstStyle/>
+          <a:p>
+            <a:pPr marL="0" indent="0">
+              <a:buNone/>
+            </a:pPr>
+            <a:r>
+              <a:rPr lang="en-US" sz="1100" b="1">
+                <a:solidFill>
+                  <a:srgbClr val="2B5FAD"/>
+                </a:solidFill>
+                <a:latin typeface="Aptos" pitchFamily="34" charset="0"/>
+                <a:ea typeface="Aptos" pitchFamily="34" charset="-122"/>
+                <a:cs typeface="Aptos" pitchFamily="34" charset="-120"/>
+              </a:rPr>
+              <a:t>REGULATORY ROUTE</a:t>
+            </a:r>
+            <a:endParaRPr lang="en-US" sz="1100"/>
+          </a:p>
+        </p:txBody>
+      </p:sp>
+      <p:sp>
+        <p:nvSpPr>
+          <p:cNvPr id="16" name="Text 14"/>
+          <p:cNvSpPr/>
+          <p:nvPr/>
+        </p:nvSpPr>
+        <p:spPr>
+          <a:xfrm>
+            <a:off x="8339328" y="2944368"/>
+            <a:ext cx="3118104" cy="2148840"/>
+          </a:xfrm>
+          <a:prstGeom prst="rect">
+            <a:avLst/>
+          </a:prstGeom>
+          <a:noFill/>
+          <a:ln/>
+        </p:spPr>
+        <p:txBody>
+          <a:bodyPr wrap="square" lIns="0" tIns="0" rIns="0" bIns="0" rtlCol="0" anchor="ctr"/>
+          <a:lstStyle/>
+          <a:p>
+            <a:pPr marL="0" indent="0">
+              <a:buNone/>
+            </a:pPr>
+            <a:r>
+              <a:rPr lang="en-US" sz="1300" b="1">
+                <a:solidFill>
+                  <a:srgbClr val="263E73"/>
+                </a:solidFill>
+                <a:latin typeface="Aptos" pitchFamily="34" charset="0"/>
+                <a:ea typeface="Aptos" pitchFamily="34" charset="-122"/>
+                <a:cs typeface="Aptos" pitchFamily="34" charset="-120"/>
+              </a:rPr>
+              <a:t>Quality: </a:t>
+            </a:r>
+            <a:r>
+              <a:rPr lang="en-US" sz="1300">
+                <a:solidFill>
+                  <a:srgbClr val="263E73"/>
+                </a:solidFill>
+                <a:latin typeface="Aptos" pitchFamily="34" charset="0"/>
+                <a:ea typeface="Aptos" pitchFamily="34" charset="-122"/>
+                <a:cs typeface="Aptos" pitchFamily="34" charset="-120"/>
+              </a:rPr>
+              <a:t>management system per ISO 13485</a:t>
+            </a:r>
+            <a:endParaRPr lang="en-US" sz="1300"/>
+          </a:p>
+          <a:p>
+            <a:pPr marL="0" indent="0">
+              <a:buNone/>
+            </a:pPr>
+            <a:endParaRPr lang="en-US" sz="500"/>
+          </a:p>
+          <a:p>
+            <a:pPr marL="0" indent="0">
+              <a:buNone/>
+            </a:pPr>
+            <a:r>
+              <a:rPr lang="en-US" sz="1300" b="1">
+                <a:solidFill>
+                  <a:srgbClr val="263E73"/>
+                </a:solidFill>
+                <a:latin typeface="Aptos" pitchFamily="34" charset="0"/>
+                <a:ea typeface="Aptos" pitchFamily="34" charset="-122"/>
+                <a:cs typeface="Aptos" pitchFamily="34" charset="-120"/>
+              </a:rPr>
+              <a:t>EU MDR: </a:t>
+            </a:r>
+            <a:r>
+              <a:rPr lang="en-US" sz="1300">
+                <a:solidFill>
+                  <a:srgbClr val="263E73"/>
+                </a:solidFill>
+                <a:latin typeface="Aptos" pitchFamily="34" charset="0"/>
+                <a:ea typeface="Aptos" pitchFamily="34" charset="-122"/>
+                <a:cs typeface="Aptos" pitchFamily="34" charset="-120"/>
+              </a:rPr>
+              <a:t>CE marking, expected class IIa (Rule 11)</a:t>
+            </a:r>
+            <a:endParaRPr lang="en-US" sz="1300"/>
+          </a:p>
+          <a:p>
+            <a:pPr marL="0" indent="0">
+              <a:buNone/>
+            </a:pPr>
+            <a:endParaRPr lang="en-US" sz="500"/>
+          </a:p>
+          <a:p>
+            <a:pPr marL="0" indent="0">
+              <a:buNone/>
+            </a:pPr>
+            <a:r>
+              <a:rPr lang="en-US" sz="1300" b="1">
+                <a:solidFill>
+                  <a:srgbClr val="263E73"/>
+                </a:solidFill>
+                <a:latin typeface="Aptos" pitchFamily="34" charset="0"/>
+                <a:ea typeface="Aptos" pitchFamily="34" charset="-122"/>
+                <a:cs typeface="Aptos" pitchFamily="34" charset="-120"/>
+              </a:rPr>
+              <a:t>Market: </a:t>
+            </a:r>
+            <a:r>
+              <a:rPr lang="en-US" sz="1300">
+                <a:solidFill>
+                  <a:srgbClr val="263E73"/>
+                </a:solidFill>
+                <a:latin typeface="Aptos" pitchFamily="34" charset="0"/>
+                <a:ea typeface="Aptos" pitchFamily="34" charset="-122"/>
+                <a:cs typeface="Aptos" pitchFamily="34" charset="-120"/>
+              </a:rPr>
+              <a:t>Europe, starting in Romania</a:t>
+            </a:r>
+            <a:endParaRPr lang="en-US" sz="1300"/>
+          </a:p>
+        </p:txBody>
+      </p:sp>
+      <p:sp>
+        <p:nvSpPr>
+          <p:cNvPr id="17" name="Shape 15"/>
+          <p:cNvSpPr/>
+          <p:nvPr/>
+        </p:nvSpPr>
+        <p:spPr>
+          <a:xfrm>
+            <a:off x="502920" y="5623560"/>
+            <a:ext cx="11155680" cy="548640"/>
+          </a:xfrm>
+          <a:prstGeom prst="roundRect">
+            <a:avLst>
+              <a:gd name="adj" fmla="val 16667"/>
+            </a:avLst>
+          </a:prstGeom>
+          <a:solidFill>
+            <a:srgbClr val="2B5FAD"/>
+          </a:solidFill>
+          <a:ln w="12700">
+            <a:solidFill>
+              <a:srgbClr val="2B5FAD"/>
+            </a:solidFill>
+            <a:prstDash val="solid"/>
+          </a:ln>
+        </p:spPr>
+        <p:txBody>
+          <a:bodyPr/>
+          <a:lstStyle/>
+          <a:p>
+            <a:endParaRPr lang="en-US"/>
+          </a:p>
+        </p:txBody>
+      </p:sp>
+      <p:sp>
+        <p:nvSpPr>
+          <p:cNvPr id="18" name="Text 16"/>
+          <p:cNvSpPr/>
+          <p:nvPr/>
+        </p:nvSpPr>
+        <p:spPr>
+          <a:xfrm>
+            <a:off x="713232" y="5705856"/>
+            <a:ext cx="10744200" cy="365760"/>
+          </a:xfrm>
+          <a:prstGeom prst="rect">
+            <a:avLst/>
+          </a:prstGeom>
+          <a:noFill/>
+          <a:ln/>
+        </p:spPr>
+        <p:txBody>
+          <a:bodyPr wrap="square" lIns="0" tIns="0" rIns="0" bIns="0" rtlCol="0" anchor="ctr"/>
+          <a:lstStyle/>
+          <a:p>
+            <a:pPr marL="0" indent="0">
+              <a:buNone/>
+            </a:pPr>
+            <a:r>
+              <a:rPr lang="en-US" sz="1400">
+                <a:solidFill>
+                  <a:srgbClr val="FFFFFF"/>
+                </a:solidFill>
+                <a:latin typeface="Aptos" pitchFamily="34" charset="0"/>
+                <a:ea typeface="Aptos" pitchFamily="34" charset="-122"/>
+                <a:cs typeface="Aptos" pitchFamily="34" charset="-120"/>
+              </a:rPr>
+              <a:t>We reach families through ADHD associations and the doctors they trust, then enter Europe with CE marking as a class IIa device.</a:t>
+            </a:r>
+            <a:endParaRPr lang="en-US" sz="1400"/>
+          </a:p>
+        </p:txBody>
+      </p:sp>
+      <p:sp>
+        <p:nvSpPr>
+          <p:cNvPr id="900" name="Brand gradient accent"/>
+          <p:cNvSpPr/>
+          <p:nvPr/>
+        </p:nvSpPr>
+        <p:spPr>
+          <a:xfrm>
+            <a:off x="502920" y="2057400"/>
+            <a:ext cx="11155680" cy="36576"/>
+          </a:xfrm>
+          <a:prstGeom prst="rect">
+            <a:avLst/>
+          </a:prstGeom>
+          <a:gradFill rotWithShape="1">
+            <a:gsLst>
+              <a:gs pos="0">
+                <a:srgbClr val="FF5757"/>
+              </a:gs>
+              <a:gs pos="100000">
+                <a:srgbClr val="8C52FF"/>
+              </a:gs>
+            </a:gsLst>
+            <a:lin ang="0" scaled="1"/>
+          </a:gradFill>
+        </p:spPr>
+        <p:txBody>
+          <a:bodyPr/>
+          <a:lstStyle/>
+          <a:p>
+            <a:endParaRPr lang="en-US"/>
+          </a:p>
+        </p:txBody>
+      </p:sp>
+    </p:spTree>
+  </p:cSld>
+  <p:clrMapOvr>
+    <a:masterClrMapping/>
+  </p:clrMapOvr>
+</p:sld>
+</file>
+
 <file path=ppt/slides/slide13.xml><?xml version="1.0" encoding="utf-8"?>
 <p:sld xmlns:a="http://schemas.openxmlformats.org/drawingml/2006/main" xmlns:r="http://schemas.openxmlformats.org/officeDocument/2006/relationships" xmlns:p="http://schemas.openxmlformats.org/presentationml/2006/main">
   <p:cSld name="Slide 12">
@@ -3772,7 +4842,7 @@
                 <a:ea typeface="Aptos" pitchFamily="34" charset="-122"/>
                 <a:cs typeface="Aptos" pitchFamily="34" charset="-120"/>
               </a:rPr>
-              <a:t>Optional A2: explain how delivery could remain viable.</a:t>
+              <a:t>Optional A3: explain how delivery could remain viable.</a:t>
             </a:r>
             <a:endParaRPr lang="en-US" sz="1600"/>
           </a:p>
@@ -3850,7 +4920,7 @@
                 <a:ea typeface="Aptos" pitchFamily="34" charset="-122"/>
                 <a:cs typeface="Aptos" pitchFamily="34" charset="-120"/>
               </a:rPr>
-              <a:t>A2 / OPTIONAL</a:t>
+              <a:t>A3 / OPTIONAL</a:t>
             </a:r>
             <a:endParaRPr lang="en-US" sz="1000"/>
           </a:p>
@@ -4798,7 +5868,7 @@
                 <a:ea typeface="Aptos" pitchFamily="34" charset="-122"/>
                 <a:cs typeface="Aptos" pitchFamily="34" charset="-120"/>
               </a:rPr>
-              <a:t>A3 / SOURCES</a:t>
+              <a:t>A4 / SOURCES</a:t>
             </a:r>
             <a:endParaRPr lang="en-US" sz="1000"/>
           </a:p>
@@ -10088,7 +11158,7 @@
                 <a:ea typeface="Aptos" pitchFamily="34" charset="-122"/>
                 <a:cs typeface="Aptos" pitchFamily="34" charset="-120"/>
               </a:rPr>
-              <a:t>Partner: </a:t>
+              <a:t>Partners: </a:t>
             </a:r>
             <a:r>
               <a:rPr lang="en-US" sz="1300">
@@ -10099,7 +11169,7 @@
                 <a:ea typeface="Aptos" pitchFamily="34" charset="-122"/>
                 <a:cs typeface="Aptos" pitchFamily="34" charset="-120"/>
               </a:rPr>
-              <a:t>child psychiatry or paediatrics team (prospective, none confirmed)</a:t>
+              <a:t>Romanian ADHD associations and leading doctors, to co-develop (to contact)</a:t>
             </a:r>
             <a:endParaRPr lang="en-US" sz="1300"/>
           </a:p>
@@ -10133,7 +11203,7 @@
                 <a:ea typeface="Aptos" pitchFamily="34" charset="-122"/>
                 <a:cs typeface="Aptos" pitchFamily="34" charset="-120"/>
               </a:rPr>
-              <a:t>parents online first, then paediatric practices and insurers</a:t>
+              <a:t>their validation drives adoption; then ISO 13485 QMS and CE marking, class IIa</a:t>
             </a:r>
             <a:endParaRPr lang="en-US" sz="1300"/>
           </a:p>

</xml_diff>